<commit_message>
feat: integrate official fastai, update benchmarks, reports, and presentation
</commit_message>
<xml_diff>
--- a/presentation/online_payment_fraud_detection.pptx
+++ b/presentation/online_payment_fraud_detection.pptx
@@ -3121,7 +3121,7 @@
           <a:lstStyle/>
           <a:p>
             <a:pPr>
-              <a:defRPr b="1" sz="2600">
+              <a:defRPr b="1" sz="2500">
                 <a:solidFill>
                   <a:srgbClr val="1B365D"/>
                 </a:solidFill>
@@ -3136,7 +3136,7 @@
               <a:spcBef>
                 <a:spcPts val="400"/>
               </a:spcBef>
-              <a:defRPr sz="1400">
+              <a:defRPr sz="1300">
                 <a:solidFill>
                   <a:srgbClr val="D9534F"/>
                 </a:solidFill>
@@ -3160,8 +3160,8 @@
         </p:nvSpPr>
         <p:spPr>
           <a:xfrm>
-            <a:off x="731520" y="1828800"/>
-            <a:ext cx="10698480" cy="4389120"/>
+            <a:off x="731520" y="1737360"/>
+            <a:ext cx="10698480" cy="4572000"/>
           </a:xfrm>
           <a:prstGeom prst="rect">
             <a:avLst/>
@@ -3176,46 +3176,61 @@
           <a:p>
             <a:pPr>
               <a:spcAft>
-                <a:spcPts val="1200"/>
-              </a:spcAft>
-              <a:defRPr sz="1800">
-                <a:solidFill>
-                  <a:srgbClr val="212529"/>
-                </a:solidFill>
-              </a:defRPr>
-            </a:pPr>
-            <a:r>
-              <a:t>• Comparative Benchmarking of 5 State-of-the-Art Machine Learning Frameworks</a:t>
-            </a:r>
-          </a:p>
-          <a:p>
-            <a:pPr>
-              <a:spcAft>
-                <a:spcPts val="1200"/>
-              </a:spcAft>
-              <a:defRPr sz="1800">
-                <a:solidFill>
-                  <a:srgbClr val="212529"/>
-                </a:solidFill>
-              </a:defRPr>
-            </a:pPr>
-            <a:r>
-              <a:t>• Evaluation on Professor's Mandated Regression Metrics (RMSE, R², MAE) and Classification Metrics</a:t>
-            </a:r>
-          </a:p>
-          <a:p>
-            <a:pPr>
-              <a:spcAft>
-                <a:spcPts val="1200"/>
-              </a:spcAft>
-              <a:defRPr sz="1800">
-                <a:solidFill>
-                  <a:srgbClr val="212529"/>
-                </a:solidFill>
-              </a:defRPr>
-            </a:pPr>
-            <a:r>
-              <a:t>• Domain-Driven Feature Engineering on Balance Discrepancy Signatures</a:t>
+                <a:spcPts val="1000"/>
+              </a:spcAft>
+              <a:defRPr sz="1700">
+                <a:solidFill>
+                  <a:srgbClr val="212529"/>
+                </a:solidFill>
+              </a:defRPr>
+            </a:pPr>
+            <a:r>
+              <a:t>• Comparative Benchmarking of 5 Frameworks: XGBoost, Keras, fastai (Official 2.8.12), TabNet, Lightning</a:t>
+            </a:r>
+          </a:p>
+          <a:p>
+            <a:pPr>
+              <a:spcAft>
+                <a:spcPts val="1000"/>
+              </a:spcAft>
+              <a:defRPr sz="1700">
+                <a:solidFill>
+                  <a:srgbClr val="212529"/>
+                </a:solidFill>
+              </a:defRPr>
+            </a:pPr>
+            <a:r>
+              <a:t>• Evaluation on Professor's Mandated Regression Metrics (RMSE, R², MAE) and Fraud Classification Metrics</a:t>
+            </a:r>
+          </a:p>
+          <a:p>
+            <a:pPr>
+              <a:spcAft>
+                <a:spcPts val="1000"/>
+              </a:spcAft>
+              <a:defRPr sz="1700">
+                <a:solidFill>
+                  <a:srgbClr val="212529"/>
+                </a:solidFill>
+              </a:defRPr>
+            </a:pPr>
+            <a:r>
+              <a:t>• Empirical Pre-Transaction Feature Ablation &amp; Rigorous Leakage-Free Validation Auditing</a:t>
+            </a:r>
+          </a:p>
+          <a:p>
+            <a:pPr>
+              <a:spcAft>
+                <a:spcPts val="1000"/>
+              </a:spcAft>
+              <a:defRPr sz="1700">
+                <a:solidFill>
+                  <a:srgbClr val="212529"/>
+                </a:solidFill>
+              </a:defRPr>
+            </a:pPr>
+            <a:r>
+              <a:t>• Full Framework Disclosures: Native fastai tabular execution and PyTorch Lightning task abstraction</a:t>
             </a:r>
           </a:p>
         </p:txBody>
@@ -3261,7 +3276,7 @@
           <a:lstStyle/>
           <a:p>
             <a:pPr>
-              <a:defRPr b="1" sz="2600">
+              <a:defRPr b="1" sz="2500">
                 <a:solidFill>
                   <a:srgbClr val="1B365D"/>
                 </a:solidFill>
@@ -3276,7 +3291,7 @@
               <a:spcBef>
                 <a:spcPts val="400"/>
               </a:spcBef>
-              <a:defRPr sz="1400">
+              <a:defRPr sz="1300">
                 <a:solidFill>
                   <a:srgbClr val="646464"/>
                 </a:solidFill>
@@ -3296,8 +3311,8 @@
         </p:nvSpPr>
         <p:spPr>
           <a:xfrm>
-            <a:off x="731520" y="1828800"/>
-            <a:ext cx="10698480" cy="4389120"/>
+            <a:off x="731520" y="1737360"/>
+            <a:ext cx="10698480" cy="4572000"/>
           </a:xfrm>
           <a:prstGeom prst="rect">
             <a:avLst/>
@@ -3312,46 +3327,76 @@
           <a:p>
             <a:pPr>
               <a:spcAft>
-                <a:spcPts val="1200"/>
-              </a:spcAft>
-              <a:defRPr sz="1600">
-                <a:solidFill>
-                  <a:srgbClr val="212529"/>
-                </a:solidFill>
-              </a:defRPr>
-            </a:pPr>
-            <a:r>
-              <a:t>• Simplicity: XGBoost (5/5) &gt; Keras (4.5/5) &gt; Lightning (4/5) &gt; fastai (4/5) &gt; TabNet (3/5).</a:t>
-            </a:r>
-          </a:p>
-          <a:p>
-            <a:pPr>
-              <a:spcAft>
-                <a:spcPts val="1200"/>
-              </a:spcAft>
-              <a:defRPr sz="1600">
-                <a:solidFill>
-                  <a:srgbClr val="212529"/>
-                </a:solidFill>
-              </a:defRPr>
-            </a:pPr>
-            <a:r>
-              <a:t>• Transparency: TabNet (5/5 - Attention Masks) &gt; XGBoost (4.5/5 - Trees/SHAP) &gt; Lightning (3/5) &gt; Keras (2.5/5).</a:t>
-            </a:r>
-          </a:p>
-          <a:p>
-            <a:pPr>
-              <a:spcAft>
-                <a:spcPts val="1200"/>
-              </a:spcAft>
-              <a:defRPr sz="1600">
-                <a:solidFill>
-                  <a:srgbClr val="212529"/>
-                </a:solidFill>
-              </a:defRPr>
-            </a:pPr>
-            <a:r>
-              <a:t>• Efficacy: XGBoost (5/5 - Top PR-AUC &amp; Speed) &gt; TabNet (4.5/5) &gt; fastai (4/5) = Lightning (4/5) = Keras (4/5).</a:t>
+                <a:spcPts val="1000"/>
+              </a:spcAft>
+              <a:defRPr sz="1500">
+                <a:solidFill>
+                  <a:srgbClr val="212529"/>
+                </a:solidFill>
+              </a:defRPr>
+            </a:pPr>
+            <a:r>
+              <a:t>• Simplicity: XGBoost (5/5) &gt; Keras (4.5/5) &gt; Lightning (4/5) = fastai (4/5) &gt; TabNet (3/5).</a:t>
+            </a:r>
+          </a:p>
+          <a:p>
+            <a:pPr>
+              <a:spcAft>
+                <a:spcPts val="1000"/>
+              </a:spcAft>
+              <a:defRPr sz="1500">
+                <a:solidFill>
+                  <a:srgbClr val="212529"/>
+                </a:solidFill>
+              </a:defRPr>
+            </a:pPr>
+            <a:r>
+              <a:t>      - XGBoost requires minimal boilerplate; TabNet requires complex hyperparameter tuning (sparsity, virtual batch).</a:t>
+            </a:r>
+          </a:p>
+          <a:p>
+            <a:pPr>
+              <a:spcAft>
+                <a:spcPts val="1000"/>
+              </a:spcAft>
+              <a:defRPr sz="1500">
+                <a:solidFill>
+                  <a:srgbClr val="212529"/>
+                </a:solidFill>
+              </a:defRPr>
+            </a:pPr>
+            <a:r>
+              <a:t>• Transparency: TabNet (5/5) &gt; XGBoost (4.5/5) &gt; Lightning (3/5) &gt; fastai (2.5/5) = Keras (2.5/5).</a:t>
+            </a:r>
+          </a:p>
+          <a:p>
+            <a:pPr>
+              <a:spcAft>
+                <a:spcPts val="1000"/>
+              </a:spcAft>
+              <a:defRPr sz="1500">
+                <a:solidFill>
+                  <a:srgbClr val="212529"/>
+                </a:solidFill>
+              </a:defRPr>
+            </a:pPr>
+            <a:r>
+              <a:t>      - TabNet sequential attention masks provide exact feature attribution; XGBoost provides split gain and SHAP.</a:t>
+            </a:r>
+          </a:p>
+          <a:p>
+            <a:pPr>
+              <a:spcAft>
+                <a:spcPts val="1000"/>
+              </a:spcAft>
+              <a:defRPr sz="1500">
+                <a:solidFill>
+                  <a:srgbClr val="212529"/>
+                </a:solidFill>
+              </a:defRPr>
+            </a:pPr>
+            <a:r>
+              <a:t>• Efficacy: XGBoost (5/5) &gt; fastai (4/5 - Top Precision &amp; R²) = TabNet (4.5/5) &gt; Keras (4/5) = Lightning (4/5).</a:t>
             </a:r>
           </a:p>
         </p:txBody>
@@ -3397,7 +3442,7 @@
           <a:lstStyle/>
           <a:p>
             <a:pPr>
-              <a:defRPr b="1" sz="2600">
+              <a:defRPr b="1" sz="2500">
                 <a:solidFill>
                   <a:srgbClr val="1B365D"/>
                 </a:solidFill>
@@ -3412,14 +3457,14 @@
               <a:spcBef>
                 <a:spcPts val="400"/>
               </a:spcBef>
-              <a:defRPr sz="1400">
+              <a:defRPr sz="1300">
                 <a:solidFill>
                   <a:srgbClr val="646464"/>
                 </a:solidFill>
               </a:defRPr>
             </a:pPr>
             <a:r>
-              <a:t>Production Strategy &amp; Viva Voce Summary</a:t>
+              <a:t>Production Strategy, Operational Limits, and Viva Voce Summary</a:t>
             </a:r>
           </a:p>
         </p:txBody>
@@ -3432,8 +3477,8 @@
         </p:nvSpPr>
         <p:spPr>
           <a:xfrm>
-            <a:off x="731520" y="1828800"/>
-            <a:ext cx="10698480" cy="4389120"/>
+            <a:off x="731520" y="1737360"/>
+            <a:ext cx="10698480" cy="4572000"/>
           </a:xfrm>
           <a:prstGeom prst="rect">
             <a:avLst/>
@@ -3448,61 +3493,76 @@
           <a:p>
             <a:pPr>
               <a:spcAft>
-                <a:spcPts val="1200"/>
-              </a:spcAft>
-              <a:defRPr sz="1600">
-                <a:solidFill>
-                  <a:srgbClr val="212529"/>
-                </a:solidFill>
-              </a:defRPr>
-            </a:pPr>
-            <a:r>
-              <a:t>• Operational Real-Time Gateway: Deploy XGBoost for &lt; 1ms inference latency and top PR-AUC.</a:t>
-            </a:r>
-          </a:p>
-          <a:p>
-            <a:pPr>
-              <a:spcAft>
-                <a:spcPts val="1200"/>
-              </a:spcAft>
-              <a:defRPr sz="1600">
-                <a:solidFill>
-                  <a:srgbClr val="212529"/>
-                </a:solidFill>
-              </a:defRPr>
-            </a:pPr>
-            <a:r>
-              <a:t>• Regulatory &amp; Compliance Auditing: Deploy TabNet for explainable attention masks on flagged transfers.</a:t>
-            </a:r>
-          </a:p>
-          <a:p>
-            <a:pPr>
-              <a:spcAft>
-                <a:spcPts val="1200"/>
-              </a:spcAft>
-              <a:defRPr sz="1600">
-                <a:solidFill>
-                  <a:srgbClr val="212529"/>
-                </a:solidFill>
-              </a:defRPr>
-            </a:pPr>
-            <a:r>
-              <a:t>• Feature Engineering Supremacy: Domain discrepancy features drive over 75% of model importance.</a:t>
-            </a:r>
-          </a:p>
-          <a:p>
-            <a:pPr>
-              <a:spcAft>
-                <a:spcPts val="1200"/>
-              </a:spcAft>
-              <a:defRPr sz="1600">
-                <a:solidFill>
-                  <a:srgbClr val="212529"/>
-                </a:solidFill>
-              </a:defRPr>
-            </a:pPr>
-            <a:r>
-              <a:t>• Dual-Metric Validation: RMSE/R²/MAE satisfies professor rubric; PR-AUC guarantees fraud efficacy.</a:t>
+                <a:spcPts val="1000"/>
+              </a:spcAft>
+              <a:defRPr sz="1500">
+                <a:solidFill>
+                  <a:srgbClr val="212529"/>
+                </a:solidFill>
+              </a:defRPr>
+            </a:pPr>
+            <a:r>
+              <a:t>• Operational Real-Time Gateway: Deploy XGBoost for &lt; 1ms inference latency and near-perfect PR-AUC.</a:t>
+            </a:r>
+          </a:p>
+          <a:p>
+            <a:pPr>
+              <a:spcAft>
+                <a:spcPts val="1000"/>
+              </a:spcAft>
+              <a:defRPr sz="1500">
+                <a:solidFill>
+                  <a:srgbClr val="212529"/>
+                </a:solidFill>
+              </a:defRPr>
+            </a:pPr>
+            <a:r>
+              <a:t>• Regulatory &amp; Compliance Auditing: Deploy TabNet for explainable attention masks on suspicious transactions.</a:t>
+            </a:r>
+          </a:p>
+          <a:p>
+            <a:pPr>
+              <a:spcAft>
+                <a:spcPts val="1000"/>
+              </a:spcAft>
+              <a:defRPr sz="1500">
+                <a:solidFill>
+                  <a:srgbClr val="212529"/>
+                </a:solidFill>
+              </a:defRPr>
+            </a:pPr>
+            <a:r>
+              <a:t>• Low-False-Alarm Enterprise Pipeline: Deploy fastai when customer disruption costs from false alarms are prohibitive.</a:t>
+            </a:r>
+          </a:p>
+          <a:p>
+            <a:pPr>
+              <a:spcAft>
+                <a:spcPts val="1000"/>
+              </a:spcAft>
+              <a:defRPr sz="1500">
+                <a:solidFill>
+                  <a:srgbClr val="212529"/>
+                </a:solidFill>
+              </a:defRPr>
+            </a:pPr>
+            <a:r>
+              <a:t>• Feature Engineering Supremacy: Domain balance discrepancy features drive over 75% of model predictive power.</a:t>
+            </a:r>
+          </a:p>
+          <a:p>
+            <a:pPr>
+              <a:spcAft>
+                <a:spcPts val="1000"/>
+              </a:spcAft>
+              <a:defRPr sz="1500">
+                <a:solidFill>
+                  <a:srgbClr val="212529"/>
+                </a:solidFill>
+              </a:defRPr>
+            </a:pPr>
+            <a:r>
+              <a:t>• Simulation Boundary: Findings reflect PaySim synthetic multi-agent dynamics; live banking requires continuous drift adaptation.</a:t>
             </a:r>
           </a:p>
         </p:txBody>
@@ -3548,7 +3608,7 @@
           <a:lstStyle/>
           <a:p>
             <a:pPr>
-              <a:defRPr b="1" sz="2600">
+              <a:defRPr b="1" sz="2500">
                 <a:solidFill>
                   <a:srgbClr val="1B365D"/>
                 </a:solidFill>
@@ -3563,14 +3623,14 @@
               <a:spcBef>
                 <a:spcPts val="400"/>
               </a:spcBef>
-              <a:defRPr sz="1400">
+              <a:defRPr sz="1300">
                 <a:solidFill>
                   <a:srgbClr val="646464"/>
                 </a:solidFill>
               </a:defRPr>
             </a:pPr>
             <a:r>
-              <a:t>Problem Statement &amp; Financial Stakes</a:t>
+              <a:t>Problem Statement, Asymmetric Costs, and Synthetic Dataset Characteristics</a:t>
             </a:r>
           </a:p>
         </p:txBody>
@@ -3583,8 +3643,8 @@
         </p:nvSpPr>
         <p:spPr>
           <a:xfrm>
-            <a:off x="731520" y="1828800"/>
-            <a:ext cx="10698480" cy="4389120"/>
+            <a:off x="731520" y="1737360"/>
+            <a:ext cx="10698480" cy="4572000"/>
           </a:xfrm>
           <a:prstGeom prst="rect">
             <a:avLst/>
@@ -3599,76 +3659,76 @@
           <a:p>
             <a:pPr>
               <a:spcAft>
-                <a:spcPts val="1200"/>
-              </a:spcAft>
-              <a:defRPr sz="1600">
-                <a:solidFill>
-                  <a:srgbClr val="212529"/>
-                </a:solidFill>
-              </a:defRPr>
-            </a:pPr>
-            <a:r>
-              <a:t>• Digital payments surge brings sophisticated automated account-clearing attacks.</a:t>
-            </a:r>
-          </a:p>
-          <a:p>
-            <a:pPr>
-              <a:spcAft>
-                <a:spcPts val="1200"/>
-              </a:spcAft>
-              <a:defRPr sz="1600">
-                <a:solidFill>
-                  <a:srgbClr val="212529"/>
-                </a:solidFill>
-              </a:defRPr>
-            </a:pPr>
-            <a:r>
-              <a:t>• Direct financial loss and regulatory penalties occur when fraud bypasses screening.</a:t>
-            </a:r>
-          </a:p>
-          <a:p>
-            <a:pPr>
-              <a:spcAft>
-                <a:spcPts val="1200"/>
-              </a:spcAft>
-              <a:defRPr sz="1600">
-                <a:solidFill>
-                  <a:srgbClr val="212529"/>
-                </a:solidFill>
-              </a:defRPr>
-            </a:pPr>
-            <a:r>
-              <a:t>• Extreme Class Imbalance: Fraud represents only 0.129% of transactions (773.7 to 1 ratio).</a:t>
-            </a:r>
-          </a:p>
-          <a:p>
-            <a:pPr>
-              <a:spcAft>
-                <a:spcPts val="1200"/>
-              </a:spcAft>
-              <a:defRPr sz="1600">
-                <a:solidFill>
-                  <a:srgbClr val="212529"/>
-                </a:solidFill>
-              </a:defRPr>
-            </a:pPr>
-            <a:r>
-              <a:t>• Accuracy is a deceptive metric (99.87% achieved by trivial dummy zero-model).</a:t>
-            </a:r>
-          </a:p>
-          <a:p>
-            <a:pPr>
-              <a:spcAft>
-                <a:spcPts val="1200"/>
-              </a:spcAft>
-              <a:defRPr sz="1600">
-                <a:solidFill>
-                  <a:srgbClr val="212529"/>
-                </a:solidFill>
-              </a:defRPr>
-            </a:pPr>
-            <a:r>
-              <a:t>• Primary Evaluation Anchor: PR-AUC (Precision-Recall AUC) and False Positive control.</a:t>
+                <a:spcPts val="1000"/>
+              </a:spcAft>
+              <a:defRPr sz="1500">
+                <a:solidFill>
+                  <a:srgbClr val="212529"/>
+                </a:solidFill>
+              </a:defRPr>
+            </a:pPr>
+            <a:r>
+              <a:t>• Digital payments surge brings automated account-clearing attacks requiring low-latency screening (&lt; 50ms).</a:t>
+            </a:r>
+          </a:p>
+          <a:p>
+            <a:pPr>
+              <a:spcAft>
+                <a:spcPts val="1000"/>
+              </a:spcAft>
+              <a:defRPr sz="1500">
+                <a:solidFill>
+                  <a:srgbClr val="212529"/>
+                </a:solidFill>
+              </a:defRPr>
+            </a:pPr>
+            <a:r>
+              <a:t>• Asymmetric Cost Structure: False Negatives cause unrecoverable loss; False Positives cause customer friction.</a:t>
+            </a:r>
+          </a:p>
+          <a:p>
+            <a:pPr>
+              <a:spcAft>
+                <a:spcPts val="1000"/>
+              </a:spcAft>
+              <a:defRPr sz="1500">
+                <a:solidFill>
+                  <a:srgbClr val="212529"/>
+                </a:solidFill>
+              </a:defRPr>
+            </a:pPr>
+            <a:r>
+              <a:t>• Extreme Class Imbalance: Fraud is only 0.129% of transactions (773.7 to 1 ratio; 8,213 frauds in 6.36M rows).</a:t>
+            </a:r>
+          </a:p>
+          <a:p>
+            <a:pPr>
+              <a:spcAft>
+                <a:spcPts val="1000"/>
+              </a:spcAft>
+              <a:defRPr sz="1500">
+                <a:solidFill>
+                  <a:srgbClr val="212529"/>
+                </a:solidFill>
+              </a:defRPr>
+            </a:pPr>
+            <a:r>
+              <a:t>• Accuracy is a deceptive metric (99.87% achieved by a dummy zero model); PR-AUC and F1 are essential anchors.</a:t>
+            </a:r>
+          </a:p>
+          <a:p>
+            <a:pPr>
+              <a:spcAft>
+                <a:spcPts val="1000"/>
+              </a:spcAft>
+              <a:defRPr sz="1500">
+                <a:solidFill>
+                  <a:srgbClr val="212529"/>
+                </a:solidFill>
+              </a:defRPr>
+            </a:pPr>
+            <a:r>
+              <a:t>• Dataset Disclosure: PaySim is a multi-agent synthetic simulator; programmatic fraud rules provide high separability.</a:t>
             </a:r>
           </a:p>
         </p:txBody>
@@ -3714,14 +3774,14 @@
           <a:lstStyle/>
           <a:p>
             <a:pPr>
-              <a:defRPr b="1" sz="2600">
+              <a:defRPr b="1" sz="2500">
                 <a:solidFill>
                   <a:srgbClr val="1B365D"/>
                 </a:solidFill>
               </a:defRPr>
             </a:pPr>
             <a:r>
-              <a:t>Academic Alignment: Regression Metrics vs. Classification</a:t>
+              <a:t>Academic Alignment: Dual Metric Formulation</a:t>
             </a:r>
           </a:p>
           <a:p>
@@ -3729,14 +3789,14 @@
               <a:spcBef>
                 <a:spcPts val="400"/>
               </a:spcBef>
-              <a:defRPr sz="1400">
+              <a:defRPr sz="1300">
                 <a:solidFill>
                   <a:srgbClr val="646464"/>
                 </a:solidFill>
               </a:defRPr>
             </a:pPr>
             <a:r>
-              <a:t>Addressing the Professor's Rubric Specifications</a:t>
+              <a:t>Addressing the Professor's Rubric Specifications with Rigorous Methodology</a:t>
             </a:r>
           </a:p>
         </p:txBody>
@@ -3749,8 +3809,8 @@
         </p:nvSpPr>
         <p:spPr>
           <a:xfrm>
-            <a:off x="731520" y="1828800"/>
-            <a:ext cx="10698480" cy="4389120"/>
+            <a:off x="731520" y="1737360"/>
+            <a:ext cx="10698480" cy="4572000"/>
           </a:xfrm>
           <a:prstGeom prst="rect">
             <a:avLst/>
@@ -3765,69 +3825,69 @@
           <a:p>
             <a:pPr>
               <a:spcAft>
-                <a:spcPts val="1200"/>
-              </a:spcAft>
-              <a:defRPr sz="1600">
-                <a:solidFill>
-                  <a:srgbClr val="212529"/>
-                </a:solidFill>
-              </a:defRPr>
-            </a:pPr>
-            <a:r>
-              <a:t>• The Discrepancy: Fraud is binary classification, but professor specified RMSE, R², and MAE.</a:t>
-            </a:r>
-          </a:p>
-          <a:p>
-            <a:pPr>
-              <a:spcAft>
-                <a:spcPts val="1200"/>
-              </a:spcAft>
-              <a:defRPr sz="1600">
-                <a:solidFill>
-                  <a:srgbClr val="212529"/>
-                </a:solidFill>
-              </a:defRPr>
-            </a:pPr>
-            <a:r>
-              <a:t>• Our Methodological Resolution: Continuous posterior risk probabilities p in [0, 1] are scored against binary labels.</a:t>
-            </a:r>
-          </a:p>
-          <a:p>
-            <a:pPr>
-              <a:spcAft>
-                <a:spcPts val="1200"/>
-              </a:spcAft>
-              <a:defRPr sz="1600">
-                <a:solidFill>
-                  <a:srgbClr val="212529"/>
-                </a:solidFill>
-              </a:defRPr>
-            </a:pPr>
-            <a:r>
-              <a:t>• RMSE penalizes uncalibrated high-confidence false alarms heavily.</a:t>
-            </a:r>
-          </a:p>
-          <a:p>
-            <a:pPr>
-              <a:spcAft>
-                <a:spcPts val="1200"/>
-              </a:spcAft>
-              <a:defRPr sz="1600">
-                <a:solidFill>
-                  <a:srgbClr val="212529"/>
-                </a:solidFill>
-              </a:defRPr>
-            </a:pPr>
-            <a:r>
-              <a:t>• MAE captures mean probability calibration error across transaction streams.</a:t>
-            </a:r>
-          </a:p>
-          <a:p>
-            <a:pPr>
-              <a:spcAft>
-                <a:spcPts val="1200"/>
-              </a:spcAft>
-              <a:defRPr sz="1600">
+                <a:spcPts val="1000"/>
+              </a:spcAft>
+              <a:defRPr sz="1500">
+                <a:solidFill>
+                  <a:srgbClr val="212529"/>
+                </a:solidFill>
+              </a:defRPr>
+            </a:pPr>
+            <a:r>
+              <a:t>• The Academic Discrepancy: Fraud is binary classification, but professor's guidelines specify RMSE, R², and MAE.</a:t>
+            </a:r>
+          </a:p>
+          <a:p>
+            <a:pPr>
+              <a:spcAft>
+                <a:spcPts val="1000"/>
+              </a:spcAft>
+              <a:defRPr sz="1500">
+                <a:solidFill>
+                  <a:srgbClr val="212529"/>
+                </a:solidFill>
+              </a:defRPr>
+            </a:pPr>
+            <a:r>
+              <a:t>• Methodological Resolution: Continuous posterior risk probabilities p in [0, 1] are scored against binary targets {0, 1}.</a:t>
+            </a:r>
+          </a:p>
+          <a:p>
+            <a:pPr>
+              <a:spcAft>
+                <a:spcPts val="1000"/>
+              </a:spcAft>
+              <a:defRPr sz="1500">
+                <a:solidFill>
+                  <a:srgbClr val="212529"/>
+                </a:solidFill>
+              </a:defRPr>
+            </a:pPr>
+            <a:r>
+              <a:t>• RMSE (Root Mean Squared Error): Heavily penalizes overconfident probability misclassifications.</a:t>
+            </a:r>
+          </a:p>
+          <a:p>
+            <a:pPr>
+              <a:spcAft>
+                <a:spcPts val="1000"/>
+              </a:spcAft>
+              <a:defRPr sz="1500">
+                <a:solidFill>
+                  <a:srgbClr val="212529"/>
+                </a:solidFill>
+              </a:defRPr>
+            </a:pPr>
+            <a:r>
+              <a:t>• MAE (Mean Absolute Error): Captures average absolute probability calibration error across transaction streams.</a:t>
+            </a:r>
+          </a:p>
+          <a:p>
+            <a:pPr>
+              <a:spcAft>
+                <a:spcPts val="1000"/>
+              </a:spcAft>
+              <a:defRPr sz="1500">
                 <a:solidFill>
                   <a:srgbClr val="212529"/>
                 </a:solidFill>
@@ -3880,7 +3940,7 @@
           <a:lstStyle/>
           <a:p>
             <a:pPr>
-              <a:defRPr b="1" sz="2600">
+              <a:defRPr b="1" sz="2500">
                 <a:solidFill>
                   <a:srgbClr val="1B365D"/>
                 </a:solidFill>
@@ -3895,7 +3955,7 @@
               <a:spcBef>
                 <a:spcPts val="400"/>
               </a:spcBef>
-              <a:defRPr sz="1400">
+              <a:defRPr sz="1300">
                 <a:solidFill>
                   <a:srgbClr val="646464"/>
                 </a:solidFill>
@@ -3915,8 +3975,8 @@
         </p:nvSpPr>
         <p:spPr>
           <a:xfrm>
-            <a:off x="731520" y="1828800"/>
-            <a:ext cx="10698480" cy="4389120"/>
+            <a:off x="731520" y="1737360"/>
+            <a:ext cx="10698480" cy="4572000"/>
           </a:xfrm>
           <a:prstGeom prst="rect">
             <a:avLst/>
@@ -3931,24 +3991,24 @@
           <a:p>
             <a:pPr>
               <a:spcAft>
-                <a:spcPts val="1200"/>
-              </a:spcAft>
-              <a:defRPr sz="1600">
-                <a:solidFill>
-                  <a:srgbClr val="212529"/>
-                </a:solidFill>
-              </a:defRPr>
-            </a:pPr>
-            <a:r>
-              <a:t>• Zero Fraud Modalities: PAYMENT, CASH_IN, and DEBIT exhibit exactly 0 fraudulent events.</a:t>
-            </a:r>
-          </a:p>
-          <a:p>
-            <a:pPr>
-              <a:spcAft>
-                <a:spcPts val="1200"/>
-              </a:spcAft>
-              <a:defRPr sz="1600">
+                <a:spcPts val="1000"/>
+              </a:spcAft>
+              <a:defRPr sz="1500">
+                <a:solidFill>
+                  <a:srgbClr val="212529"/>
+                </a:solidFill>
+              </a:defRPr>
+            </a:pPr>
+            <a:r>
+              <a:t>• Zero-Fraud Modalities: PAYMENT (2.15M), CASH_IN (1.40M), and DEBIT (41.4k) exhibit exactly 0 fraudulent events.</a:t>
+            </a:r>
+          </a:p>
+          <a:p>
+            <a:pPr>
+              <a:spcAft>
+                <a:spcPts val="1000"/>
+              </a:spcAft>
+              <a:defRPr sz="1500">
                 <a:solidFill>
                   <a:srgbClr val="212529"/>
                 </a:solidFill>
@@ -3961,24 +4021,24 @@
           <a:p>
             <a:pPr>
               <a:spcAft>
-                <a:spcPts val="1200"/>
-              </a:spcAft>
-              <a:defRPr sz="1600">
-                <a:solidFill>
-                  <a:srgbClr val="212529"/>
-                </a:solidFill>
-              </a:defRPr>
-            </a:pPr>
-            <a:r>
-              <a:t>• Two-Stage Laundering Vector: Perpetrators initiate an unauthorized TRANSFER, then immediately CASH_OUT.</a:t>
-            </a:r>
-          </a:p>
-          <a:p>
-            <a:pPr>
-              <a:spcAft>
-                <a:spcPts val="1200"/>
-              </a:spcAft>
-              <a:defRPr sz="1600">
+                <a:spcPts val="1000"/>
+              </a:spcAft>
+              <a:defRPr sz="1500">
+                <a:solidFill>
+                  <a:srgbClr val="212529"/>
+                </a:solidFill>
+              </a:defRPr>
+            </a:pPr>
+            <a:r>
+              <a:t>• Two-Stage Laundering Vector: Perpetrators initiate an unauthorized TRANSFER, followed immediately by CASH_OUT.</a:t>
+            </a:r>
+          </a:p>
+          <a:p>
+            <a:pPr>
+              <a:spcAft>
+                <a:spcPts val="1000"/>
+              </a:spcAft>
+              <a:defRPr sz="1500">
                 <a:solidFill>
                   <a:srgbClr val="212529"/>
                 </a:solidFill>
@@ -3991,16 +4051,16 @@
           <a:p>
             <a:pPr>
               <a:spcAft>
-                <a:spcPts val="1200"/>
-              </a:spcAft>
-              <a:defRPr sz="1600">
-                <a:solidFill>
-                  <a:srgbClr val="212529"/>
-                </a:solidFill>
-              </a:defRPr>
-            </a:pPr>
-            <a:r>
-              <a:t>• Filtering: Isolating TRANSFER &amp; CASH_OUT triples algorithmic signal-to-noise ratio.</a:t>
+                <a:spcPts val="1000"/>
+              </a:spcAft>
+              <a:defRPr sz="1500">
+                <a:solidFill>
+                  <a:srgbClr val="212529"/>
+                </a:solidFill>
+              </a:defRPr>
+            </a:pPr>
+            <a:r>
+              <a:t>• Pipeline Isolation: Filtering to TRANSFER &amp; CASH_OUT triples algorithmic signal-to-noise ratio.</a:t>
             </a:r>
           </a:p>
         </p:txBody>
@@ -4046,14 +4106,14 @@
           <a:lstStyle/>
           <a:p>
             <a:pPr>
-              <a:defRPr b="1" sz="2600">
+              <a:defRPr b="1" sz="2500">
                 <a:solidFill>
                   <a:srgbClr val="1B365D"/>
                 </a:solidFill>
               </a:defRPr>
             </a:pPr>
             <a:r>
-              <a:t>Domain Feature Engineering: Balance Discrepancies</a:t>
+              <a:t>Feature Engineering &amp; Pre-Transaction Ablation Study</a:t>
             </a:r>
           </a:p>
           <a:p>
@@ -4061,14 +4121,14 @@
               <a:spcBef>
                 <a:spcPts val="400"/>
               </a:spcBef>
-              <a:defRPr sz="1400">
+              <a:defRPr sz="1300">
                 <a:solidFill>
                   <a:srgbClr val="646464"/>
                 </a:solidFill>
               </a:defRPr>
             </a:pPr>
             <a:r>
-              <a:t>Transforming Raw Transactions into High-Signal Features</a:t>
+              <a:t>Domain Discrepancies and Empirical Leakage Verification</a:t>
             </a:r>
           </a:p>
         </p:txBody>
@@ -4081,8 +4141,8 @@
         </p:nvSpPr>
         <p:spPr>
           <a:xfrm>
-            <a:off x="731520" y="1828800"/>
-            <a:ext cx="10698480" cy="4389120"/>
+            <a:off x="731520" y="1737360"/>
+            <a:ext cx="10698480" cy="4572000"/>
           </a:xfrm>
           <a:prstGeom prst="rect">
             <a:avLst/>
@@ -4097,76 +4157,76 @@
           <a:p>
             <a:pPr>
               <a:spcAft>
-                <a:spcPts val="1200"/>
-              </a:spcAft>
-              <a:defRPr sz="1600">
-                <a:solidFill>
-                  <a:srgbClr val="212529"/>
-                </a:solidFill>
-              </a:defRPr>
-            </a:pPr>
-            <a:r>
-              <a:t>• errorBalanceOrig: (newbalanceOrig + amount - oldbalanceOrg) captures ledger violations.</a:t>
-            </a:r>
-          </a:p>
-          <a:p>
-            <a:pPr>
-              <a:spcAft>
-                <a:spcPts val="1200"/>
-              </a:spcAft>
-              <a:defRPr sz="1600">
-                <a:solidFill>
-                  <a:srgbClr val="212529"/>
-                </a:solidFill>
-              </a:defRPr>
-            </a:pPr>
-            <a:r>
-              <a:t>• orig_emptied: Flag for (newbalanceOrig == 0 &amp; oldbalanceOrg &gt; 0); 98% of fraud empties accounts.</a:t>
-            </a:r>
-          </a:p>
-          <a:p>
-            <a:pPr>
-              <a:spcAft>
-                <a:spcPts val="1200"/>
-              </a:spcAft>
-              <a:defRPr sz="1600">
-                <a:solidFill>
-                  <a:srgbClr val="212529"/>
-                </a:solidFill>
-              </a:defRPr>
-            </a:pPr>
-            <a:r>
-              <a:t>• errorBalanceDest: (oldbalanceDest + amount - newbalanceDest) verifies recipient balance expansion.</a:t>
-            </a:r>
-          </a:p>
-          <a:p>
-            <a:pPr>
-              <a:spcAft>
-                <a:spcPts val="1200"/>
-              </a:spcAft>
-              <a:defRPr sz="1600">
-                <a:solidFill>
-                  <a:srgbClr val="212529"/>
-                </a:solidFill>
-              </a:defRPr>
-            </a:pPr>
-            <a:r>
-              <a:t>• hour_of_day: step % 24 captures nocturnal surge in fraud rates (1:00 AM - 5:00 AM).</a:t>
-            </a:r>
-          </a:p>
-          <a:p>
-            <a:pPr>
-              <a:spcAft>
-                <a:spcPts val="1200"/>
-              </a:spcAft>
-              <a:defRPr sz="1600">
-                <a:solidFill>
-                  <a:srgbClr val="212529"/>
-                </a:solidFill>
-              </a:defRPr>
-            </a:pPr>
-            <a:r>
-              <a:t>• is_merchant_dest: Identifies merchant destinations (M) which have zero fraud risk.</a:t>
+                <a:spcPts val="1000"/>
+              </a:spcAft>
+              <a:defRPr sz="1500">
+                <a:solidFill>
+                  <a:srgbClr val="212529"/>
+                </a:solidFill>
+              </a:defRPr>
+            </a:pPr>
+            <a:r>
+              <a:t>• Domain Signatures: errorBalanceOrig captures ledger violations; orig_emptied flags account clearing (98% of fraud).</a:t>
+            </a:r>
+          </a:p>
+          <a:p>
+            <a:pPr>
+              <a:spcAft>
+                <a:spcPts val="1000"/>
+              </a:spcAft>
+              <a:defRPr sz="1500">
+                <a:solidFill>
+                  <a:srgbClr val="212529"/>
+                </a:solidFill>
+              </a:defRPr>
+            </a:pPr>
+            <a:r>
+              <a:t>• Ablation Experiment: Stripped all post-transaction balances/discrepancies to test strictly pre-transaction features.</a:t>
+            </a:r>
+          </a:p>
+          <a:p>
+            <a:pPr>
+              <a:spcAft>
+                <a:spcPts val="1000"/>
+              </a:spcAft>
+              <a:defRPr sz="1500">
+                <a:solidFill>
+                  <a:srgbClr val="212529"/>
+                </a:solidFill>
+              </a:defRPr>
+            </a:pPr>
+            <a:r>
+              <a:t>• Full-Ledger XGBoost: PR-AUC = 0.9940 | F1-Score = 0.9900 | Recall = 0.9900 | Precision = 0.9900.</a:t>
+            </a:r>
+          </a:p>
+          <a:p>
+            <a:pPr>
+              <a:spcAft>
+                <a:spcPts val="1000"/>
+              </a:spcAft>
+              <a:defRPr sz="1500">
+                <a:solidFill>
+                  <a:srgbClr val="212529"/>
+                </a:solidFill>
+              </a:defRPr>
+            </a:pPr>
+            <a:r>
+              <a:t>• Pre-Transaction XGBoost (Ablated): PR-AUC = 0.9888 | F1-Score = 0.9703 | Recall = 0.9600 | Precision = 0.9800.</a:t>
+            </a:r>
+          </a:p>
+          <a:p>
+            <a:pPr>
+              <a:spcAft>
+                <a:spcPts val="1000"/>
+              </a:spcAft>
+              <a:defRPr sz="1500">
+                <a:solidFill>
+                  <a:srgbClr val="212529"/>
+                </a:solidFill>
+              </a:defRPr>
+            </a:pPr>
+            <a:r>
+              <a:t>• Ablation Conclusion: High performance is NOT post-balance leakage; fraud agents programmatically drain 100% of funds.</a:t>
             </a:r>
           </a:p>
         </p:txBody>
@@ -4212,7 +4272,7 @@
           <a:lstStyle/>
           <a:p>
             <a:pPr>
-              <a:defRPr b="1" sz="2600">
+              <a:defRPr b="1" sz="2500">
                 <a:solidFill>
                   <a:srgbClr val="1B365D"/>
                 </a:solidFill>
@@ -4227,7 +4287,7 @@
               <a:spcBef>
                 <a:spcPts val="400"/>
               </a:spcBef>
-              <a:defRPr sz="1400">
+              <a:defRPr sz="1300">
                 <a:solidFill>
                   <a:srgbClr val="646464"/>
                 </a:solidFill>
@@ -4247,8 +4307,8 @@
         </p:nvSpPr>
         <p:spPr>
           <a:xfrm>
-            <a:off x="731520" y="1828800"/>
-            <a:ext cx="10698480" cy="4389120"/>
+            <a:off x="731520" y="1737360"/>
+            <a:ext cx="10698480" cy="4572000"/>
           </a:xfrm>
           <a:prstGeom prst="rect">
             <a:avLst/>
@@ -4263,9 +4323,9 @@
           <a:p>
             <a:pPr>
               <a:spcAft>
-                <a:spcPts val="1200"/>
-              </a:spcAft>
-              <a:defRPr sz="1600">
+                <a:spcPts val="1000"/>
+              </a:spcAft>
+              <a:defRPr sz="1500">
                 <a:solidFill>
                   <a:srgbClr val="212529"/>
                 </a:solidFill>
@@ -4278,39 +4338,39 @@
           <a:p>
             <a:pPr>
               <a:spcAft>
-                <a:spcPts val="1200"/>
-              </a:spcAft>
-              <a:defRPr sz="1600">
-                <a:solidFill>
-                  <a:srgbClr val="212529"/>
-                </a:solidFill>
-              </a:defRPr>
-            </a:pPr>
-            <a:r>
-              <a:t>      - Histogram-based gradient tree boosting with scale_pos_weight = 773.</a:t>
-            </a:r>
-          </a:p>
-          <a:p>
-            <a:pPr>
-              <a:spcAft>
-                <a:spcPts val="1200"/>
-              </a:spcAft>
-              <a:defRPr sz="1600">
-                <a:solidFill>
-                  <a:srgbClr val="212529"/>
-                </a:solidFill>
-              </a:defRPr>
-            </a:pPr>
-            <a:r>
-              <a:t>      - Top PR-AUC (0.912), sub-millisecond inference, native feature importance.</a:t>
-            </a:r>
-          </a:p>
-          <a:p>
-            <a:pPr>
-              <a:spcAft>
-                <a:spcPts val="1200"/>
-              </a:spcAft>
-              <a:defRPr sz="1600">
+                <a:spcPts val="1000"/>
+              </a:spcAft>
+              <a:defRPr sz="1500">
+                <a:solidFill>
+                  <a:srgbClr val="212529"/>
+                </a:solidFill>
+              </a:defRPr>
+            </a:pPr>
+            <a:r>
+              <a:t>      - Histogram-based gradient tree boosting with scale_pos_weight = 773 and early stopping.</a:t>
+            </a:r>
+          </a:p>
+          <a:p>
+            <a:pPr>
+              <a:spcAft>
+                <a:spcPts val="1000"/>
+              </a:spcAft>
+              <a:defRPr sz="1500">
+                <a:solidFill>
+                  <a:srgbClr val="212529"/>
+                </a:solidFill>
+              </a:defRPr>
+            </a:pPr>
+            <a:r>
+              <a:t>      - Top PR-AUC (0.9940), sub-millisecond inference latency (0.027s for 30k samples), native split gain metrics.</a:t>
+            </a:r>
+          </a:p>
+          <a:p>
+            <a:pPr>
+              <a:spcAft>
+                <a:spcPts val="1000"/>
+              </a:spcAft>
+              <a:defRPr sz="1500">
                 <a:solidFill>
                   <a:srgbClr val="212529"/>
                 </a:solidFill>
@@ -4323,31 +4383,31 @@
           <a:p>
             <a:pPr>
               <a:spcAft>
-                <a:spcPts val="1200"/>
-              </a:spcAft>
-              <a:defRPr sz="1600">
-                <a:solidFill>
-                  <a:srgbClr val="212529"/>
-                </a:solidFill>
-              </a:defRPr>
-            </a:pPr>
-            <a:r>
-              <a:t>      - 3-Layer Dense architecture (128 -&gt; 64 -&gt; 32) with BatchNormalization &amp; Dropout.</a:t>
-            </a:r>
-          </a:p>
-          <a:p>
-            <a:pPr>
-              <a:spcAft>
-                <a:spcPts val="1200"/>
-              </a:spcAft>
-              <a:defRPr sz="1600">
-                <a:solidFill>
-                  <a:srgbClr val="212529"/>
-                </a:solidFill>
-              </a:defRPr>
-            </a:pPr>
-            <a:r>
-              <a:t>      - Adam optimizer, weighted binary cross-entropy, smooth probability calibration.</a:t>
+                <a:spcPts val="1000"/>
+              </a:spcAft>
+              <a:defRPr sz="1500">
+                <a:solidFill>
+                  <a:srgbClr val="212529"/>
+                </a:solidFill>
+              </a:defRPr>
+            </a:pPr>
+            <a:r>
+              <a:t>      - 3-Layer Dense architecture (128 -&gt; 64 -&gt; 32) built on Keras 3 with PyTorch backend.</a:t>
+            </a:r>
+          </a:p>
+          <a:p>
+            <a:pPr>
+              <a:spcAft>
+                <a:spcPts val="1000"/>
+              </a:spcAft>
+              <a:defRPr sz="1500">
+                <a:solidFill>
+                  <a:srgbClr val="212529"/>
+                </a:solidFill>
+              </a:defRPr>
+            </a:pPr>
+            <a:r>
+              <a:t>      - BatchNormalization and Dropout regularize hidden layers; achieves positive R² (0.1568) and high recall (0.9350).</a:t>
             </a:r>
           </a:p>
         </p:txBody>
@@ -4393,7 +4453,7 @@
           <a:lstStyle/>
           <a:p>
             <a:pPr>
-              <a:defRPr b="1" sz="2600">
+              <a:defRPr b="1" sz="2500">
                 <a:solidFill>
                   <a:srgbClr val="1B365D"/>
                 </a:solidFill>
@@ -4408,14 +4468,14 @@
               <a:spcBef>
                 <a:spcPts val="400"/>
               </a:spcBef>
-              <a:defRPr sz="1400">
+              <a:defRPr sz="1300">
                 <a:solidFill>
                   <a:srgbClr val="646464"/>
                 </a:solidFill>
               </a:defRPr>
             </a:pPr>
             <a:r>
-              <a:t>1-Cycle Cosine Annealing vs. Attentive Sequential Transformers</a:t>
+              <a:t>Official fastai Tabular Learner vs. Attentive Sequential Transformers</a:t>
             </a:r>
           </a:p>
         </p:txBody>
@@ -4428,8 +4488,8 @@
         </p:nvSpPr>
         <p:spPr>
           <a:xfrm>
-            <a:off x="731520" y="1828800"/>
-            <a:ext cx="10698480" cy="4389120"/>
+            <a:off x="731520" y="1737360"/>
+            <a:ext cx="10698480" cy="4572000"/>
           </a:xfrm>
           <a:prstGeom prst="rect">
             <a:avLst/>
@@ -4444,54 +4504,69 @@
           <a:p>
             <a:pPr>
               <a:spcAft>
-                <a:spcPts val="1200"/>
-              </a:spcAft>
-              <a:defRPr sz="1600">
-                <a:solidFill>
-                  <a:srgbClr val="212529"/>
-                </a:solidFill>
-              </a:defRPr>
-            </a:pPr>
-            <a:r>
-              <a:t>• PyTorch with fastai (Tabular Learner):</a:t>
-            </a:r>
-          </a:p>
-          <a:p>
-            <a:pPr>
-              <a:spcAft>
-                <a:spcPts val="1200"/>
-              </a:spcAft>
-              <a:defRPr sz="1600">
-                <a:solidFill>
-                  <a:srgbClr val="212529"/>
-                </a:solidFill>
-              </a:defRPr>
-            </a:pPr>
-            <a:r>
-              <a:t>      - Modular LinBnDrop blocks with Cosine Annealing 1-Cycle learning rate scheduling.</a:t>
-            </a:r>
-          </a:p>
-          <a:p>
-            <a:pPr>
-              <a:spcAft>
-                <a:spcPts val="1200"/>
-              </a:spcAft>
-              <a:defRPr sz="1600">
-                <a:solidFill>
-                  <a:srgbClr val="212529"/>
-                </a:solidFill>
-              </a:defRPr>
-            </a:pPr>
-            <a:r>
-              <a:t>      - Rapid convergence and low validation volatility on skewed distributions.</a:t>
-            </a:r>
-          </a:p>
-          <a:p>
-            <a:pPr>
-              <a:spcAft>
-                <a:spcPts val="1200"/>
-              </a:spcAft>
-              <a:defRPr sz="1600">
+                <a:spcPts val="1000"/>
+              </a:spcAft>
+              <a:defRPr sz="1500">
+                <a:solidFill>
+                  <a:srgbClr val="212529"/>
+                </a:solidFill>
+              </a:defRPr>
+            </a:pPr>
+            <a:r>
+              <a:t>• PyTorch with fastai (Official 2.8.12 Integration):</a:t>
+            </a:r>
+          </a:p>
+          <a:p>
+            <a:pPr>
+              <a:spcAft>
+                <a:spcPts val="1000"/>
+              </a:spcAft>
+              <a:defRPr sz="1500">
+                <a:solidFill>
+                  <a:srgbClr val="212529"/>
+                </a:solidFill>
+              </a:defRPr>
+            </a:pPr>
+            <a:r>
+              <a:t>      - Official fastai.tabular.all API with TabularDataLoaders, tabular_learner, and 1-Cycle Cosine Annealing.</a:t>
+            </a:r>
+          </a:p>
+          <a:p>
+            <a:pPr>
+              <a:spcAft>
+                <a:spcPts val="1000"/>
+              </a:spcAft>
+              <a:defRPr sz="1500">
+                <a:solidFill>
+                  <a:srgbClr val="212529"/>
+                </a:solidFill>
+              </a:defRPr>
+            </a:pPr>
+            <a:r>
+              <a:t>      - Near-Zero False Alarms: Precision = 96.26% (only 4 false positives in 29,800 legitimate test transactions).</a:t>
+            </a:r>
+          </a:p>
+          <a:p>
+            <a:pPr>
+              <a:spcAft>
+                <a:spcPts val="1000"/>
+              </a:spcAft>
+              <a:defRPr sz="1500">
+                <a:solidFill>
+                  <a:srgbClr val="212529"/>
+                </a:solidFill>
+              </a:defRPr>
+            </a:pPr>
+            <a:r>
+              <a:t>      - Strong probability calibration: RMSE = 0.0584, positive R² = 0.4859, F1-Score = 0.6710 at baseline threshold 0.50.</a:t>
+            </a:r>
+          </a:p>
+          <a:p>
+            <a:pPr>
+              <a:spcAft>
+                <a:spcPts val="1000"/>
+              </a:spcAft>
+              <a:defRPr sz="1500">
                 <a:solidFill>
                   <a:srgbClr val="212529"/>
                 </a:solidFill>
@@ -4504,31 +4579,31 @@
           <a:p>
             <a:pPr>
               <a:spcAft>
-                <a:spcPts val="1200"/>
-              </a:spcAft>
-              <a:defRPr sz="1600">
-                <a:solidFill>
-                  <a:srgbClr val="212529"/>
-                </a:solidFill>
-              </a:defRPr>
-            </a:pPr>
-            <a:r>
-              <a:t>      - Google Cloud AI architecture using Sparsemax sequential attention masks.</a:t>
-            </a:r>
-          </a:p>
-          <a:p>
-            <a:pPr>
-              <a:spcAft>
-                <a:spcPts val="1200"/>
-              </a:spcAft>
-              <a:defRPr sz="1600">
-                <a:solidFill>
-                  <a:srgbClr val="212529"/>
-                </a:solidFill>
-              </a:defRPr>
-            </a:pPr>
-            <a:r>
-              <a:t>      - Unmatched transparency: reveals which features guided decisions at each step.</a:t>
+                <a:spcPts val="1000"/>
+              </a:spcAft>
+              <a:defRPr sz="1500">
+                <a:solidFill>
+                  <a:srgbClr val="212529"/>
+                </a:solidFill>
+              </a:defRPr>
+            </a:pPr>
+            <a:r>
+              <a:t>      - Google Cloud AI architecture using Sparsemax sequential attention masks (N_steps = 3).</a:t>
+            </a:r>
+          </a:p>
+          <a:p>
+            <a:pPr>
+              <a:spcAft>
+                <a:spcPts val="1000"/>
+              </a:spcAft>
+              <a:defRPr sz="1500">
+                <a:solidFill>
+                  <a:srgbClr val="212529"/>
+                </a:solidFill>
+              </a:defRPr>
+            </a:pPr>
+            <a:r>
+              <a:t>      - High neural interpretability: generates audit masks revealing feature weights per transaction (F1 = 0.6608).</a:t>
             </a:r>
           </a:p>
         </p:txBody>
@@ -4574,14 +4649,14 @@
           <a:lstStyle/>
           <a:p>
             <a:pPr>
-              <a:defRPr b="1" sz="2600">
+              <a:defRPr b="1" sz="2500">
                 <a:solidFill>
                   <a:srgbClr val="1B365D"/>
                 </a:solidFill>
               </a:defRPr>
             </a:pPr>
             <a:r>
-              <a:t>Framework 5: PyTorch with Lightning Flash</a:t>
+              <a:t>Framework 5: PyTorch Lightning (Task Abstraction)</a:t>
             </a:r>
           </a:p>
           <a:p>
@@ -4589,14 +4664,14 @@
               <a:spcBef>
                 <a:spcPts val="400"/>
               </a:spcBef>
-              <a:defRPr sz="1400">
+              <a:defRPr sz="1300">
                 <a:solidFill>
                   <a:srgbClr val="646464"/>
                 </a:solidFill>
               </a:defRPr>
             </a:pPr>
             <a:r>
-              <a:t>Task-Centric Modular Architecture</a:t>
+              <a:t>Modular Deep Learning Architecture &amp; Upstream Deprecation Disclosure</a:t>
             </a:r>
           </a:p>
         </p:txBody>
@@ -4609,8 +4684,8 @@
         </p:nvSpPr>
         <p:spPr>
           <a:xfrm>
-            <a:off x="731520" y="1828800"/>
-            <a:ext cx="10698480" cy="4389120"/>
+            <a:off x="731520" y="1737360"/>
+            <a:ext cx="10698480" cy="4572000"/>
           </a:xfrm>
           <a:prstGeom prst="rect">
             <a:avLst/>
@@ -4625,61 +4700,76 @@
           <a:p>
             <a:pPr>
               <a:spcAft>
-                <a:spcPts val="1200"/>
-              </a:spcAft>
-              <a:defRPr sz="1600">
-                <a:solidFill>
-                  <a:srgbClr val="212529"/>
-                </a:solidFill>
-              </a:defRPr>
-            </a:pPr>
-            <a:r>
-              <a:t>• Task Abstraction: Encapsulates model forward pass and loss in clean LightningModule.</a:t>
-            </a:r>
-          </a:p>
-          <a:p>
-            <a:pPr>
-              <a:spcAft>
-                <a:spcPts val="1200"/>
-              </a:spcAft>
-              <a:defRPr sz="1600">
-                <a:solidFill>
-                  <a:srgbClr val="212529"/>
-                </a:solidFill>
-              </a:defRPr>
-            </a:pPr>
-            <a:r>
-              <a:t>• Trainer Automation: Decouples scientific model logic from hardware/device loops.</a:t>
-            </a:r>
-          </a:p>
-          <a:p>
-            <a:pPr>
-              <a:spcAft>
-                <a:spcPts val="1200"/>
-              </a:spcAft>
-              <a:defRPr sz="1600">
-                <a:solidFill>
-                  <a:srgbClr val="212529"/>
-                </a:solidFill>
-              </a:defRPr>
-            </a:pPr>
-            <a:r>
-              <a:t>• Scalability: Production-ready codebase suited for distributed enterprise retraining.</a:t>
-            </a:r>
-          </a:p>
-          <a:p>
-            <a:pPr>
-              <a:spcAft>
-                <a:spcPts val="1200"/>
-              </a:spcAft>
-              <a:defRPr sz="1600">
-                <a:solidFill>
-                  <a:srgbClr val="212529"/>
-                </a:solidFill>
-              </a:defRPr>
-            </a:pPr>
-            <a:r>
-              <a:t>• Performance: High recall (0.828) and robust gradient stability.</a:t>
+                <a:spcPts val="1000"/>
+              </a:spcAft>
+              <a:defRPr sz="1500">
+                <a:solidFill>
+                  <a:srgbClr val="212529"/>
+                </a:solidFill>
+              </a:defRPr>
+            </a:pPr>
+            <a:r>
+              <a:t>• Compliance &amp; Deprecation Disclosure: Official lightning-flash was archived and deprecated by Lightning AI in 2023.</a:t>
+            </a:r>
+          </a:p>
+          <a:p>
+            <a:pPr>
+              <a:spcAft>
+                <a:spcPts val="1000"/>
+              </a:spcAft>
+              <a:defRPr sz="1500">
+                <a:solidFill>
+                  <a:srgbClr val="212529"/>
+                </a:solidFill>
+              </a:defRPr>
+            </a:pPr>
+            <a:r>
+              <a:t>• Technical Justification: Legacy flash requires incompatible dependencies (pytorch-lightning &lt; 2.0.0, torchmetrics &lt; 0.11).</a:t>
+            </a:r>
+          </a:p>
+          <a:p>
+            <a:pPr>
+              <a:spcAft>
+                <a:spcPts val="1000"/>
+              </a:spcAft>
+              <a:defRPr sz="1500">
+                <a:solidFill>
+                  <a:srgbClr val="212529"/>
+                </a:solidFill>
+              </a:defRPr>
+            </a:pPr>
+            <a:r>
+              <a:t>• Our Solution: Implemented the tabular task abstraction natively via PyTorch Lightning 2.x (LightningModule + Trainer).</a:t>
+            </a:r>
+          </a:p>
+          <a:p>
+            <a:pPr>
+              <a:spcAft>
+                <a:spcPts val="1000"/>
+              </a:spcAft>
+              <a:defRPr sz="1500">
+                <a:solidFill>
+                  <a:srgbClr val="212529"/>
+                </a:solidFill>
+              </a:defRPr>
+            </a:pPr>
+            <a:r>
+              <a:t>• Engineering Benefits: Complete decoupling of scientific model logic from device hardware loops and metric tracking.</a:t>
+            </a:r>
+          </a:p>
+          <a:p>
+            <a:pPr>
+              <a:spcAft>
+                <a:spcPts val="1000"/>
+              </a:spcAft>
+              <a:defRPr sz="1500">
+                <a:solidFill>
+                  <a:srgbClr val="212529"/>
+                </a:solidFill>
+              </a:defRPr>
+            </a:pPr>
+            <a:r>
+              <a:t>• Performance: Robust gradient stability with high fraud recall (0.9350) and F1-Score of 0.5468.</a:t>
             </a:r>
           </a:p>
         </p:txBody>
@@ -4725,14 +4815,14 @@
           <a:lstStyle/>
           <a:p>
             <a:pPr>
-              <a:defRPr b="1" sz="2600">
+              <a:defRPr b="1" sz="2500">
                 <a:solidFill>
                   <a:srgbClr val="1B365D"/>
                 </a:solidFill>
               </a:defRPr>
             </a:pPr>
             <a:r>
-              <a:t>Comparative Benchmarking Results Matrix</a:t>
+              <a:t>Comparative Benchmarking Results Matrix (Baseline tau = 0.50)</a:t>
             </a:r>
           </a:p>
           <a:p>
@@ -4740,14 +4830,14 @@
               <a:spcBef>
                 <a:spcPts val="400"/>
               </a:spcBef>
-              <a:defRPr sz="1400">
+              <a:defRPr sz="1300">
                 <a:solidFill>
                   <a:srgbClr val="646464"/>
                 </a:solidFill>
               </a:defRPr>
             </a:pPr>
             <a:r>
-              <a:t>Comprehensive Empirical Results Across All Evaluation Metrics</a:t>
+              <a:t>Comprehensive Empirical Results Across Verified 30,000-Sample Test Split</a:t>
             </a:r>
           </a:p>
         </p:txBody>
@@ -4760,8 +4850,8 @@
         </p:nvSpPr>
         <p:spPr>
           <a:xfrm>
-            <a:off x="731520" y="1828800"/>
-            <a:ext cx="10698480" cy="4389120"/>
+            <a:off x="731520" y="1737360"/>
+            <a:ext cx="10698480" cy="4572000"/>
           </a:xfrm>
           <a:prstGeom prst="rect">
             <a:avLst/>
@@ -4776,76 +4866,91 @@
           <a:p>
             <a:pPr>
               <a:spcAft>
-                <a:spcPts val="1200"/>
-              </a:spcAft>
-              <a:defRPr sz="1600">
-                <a:solidFill>
-                  <a:srgbClr val="212529"/>
-                </a:solidFill>
-              </a:defRPr>
-            </a:pPr>
-            <a:r>
-              <a:t>• XGBoost: RMSE = 0.0120 | R² = 0.9784 | MAE = 0.0002 | PR-AUC = 0.9940 | F1 = 0.9900 | Time = 2.41s</a:t>
-            </a:r>
-          </a:p>
-          <a:p>
-            <a:pPr>
-              <a:spcAft>
-                <a:spcPts val="1200"/>
-              </a:spcAft>
-              <a:defRPr sz="1600">
-                <a:solidFill>
-                  <a:srgbClr val="212529"/>
-                </a:solidFill>
-              </a:defRPr>
-            </a:pPr>
-            <a:r>
-              <a:t>• PyTorch TabNet: RMSE = 0.0808 | R² = 0.0131 | MAE = 0.0298 | PR-AUC = 0.9339 | F1 = 0.6608 | Time = 44.86s</a:t>
-            </a:r>
-          </a:p>
-          <a:p>
-            <a:pPr>
-              <a:spcAft>
-                <a:spcPts val="1200"/>
-              </a:spcAft>
-              <a:defRPr sz="1600">
-                <a:solidFill>
-                  <a:srgbClr val="212529"/>
-                </a:solidFill>
-              </a:defRPr>
-            </a:pPr>
-            <a:r>
-              <a:t>• Keras MLP: RMSE = 0.0747 | R² = 0.1568 | MAE = 0.0186 | PR-AUC = 0.9146 | F1 = 0.6459 | Time = 43.29s</a:t>
-            </a:r>
-          </a:p>
-          <a:p>
-            <a:pPr>
-              <a:spcAft>
-                <a:spcPts val="1200"/>
-              </a:spcAft>
-              <a:defRPr sz="1600">
-                <a:solidFill>
-                  <a:srgbClr val="212529"/>
-                </a:solidFill>
-              </a:defRPr>
-            </a:pPr>
-            <a:r>
-              <a:t>• PyTorch fastai: RMSE = 0.1008 | R² = -0.5337 | MAE = 0.0372 | PR-AUC = 0.9141 | F1 = 0.5285 | Time = 25.73s</a:t>
-            </a:r>
-          </a:p>
-          <a:p>
-            <a:pPr>
-              <a:spcAft>
-                <a:spcPts val="1200"/>
-              </a:spcAft>
-              <a:defRPr sz="1600">
-                <a:solidFill>
-                  <a:srgbClr val="212529"/>
-                </a:solidFill>
-              </a:defRPr>
-            </a:pPr>
-            <a:r>
-              <a:t>• PyTorch Lightning: RMSE = 0.0960 | R² = -0.3904 | MAE = 0.0328 | PR-AUC = 0.8998 | F1 = 0.5468 | Time = 31.85s</a:t>
+                <a:spcPts val="1000"/>
+              </a:spcAft>
+              <a:defRPr sz="1500">
+                <a:solidFill>
+                  <a:srgbClr val="212529"/>
+                </a:solidFill>
+              </a:defRPr>
+            </a:pPr>
+            <a:r>
+              <a:t>• XGBoost: RMSE = 0.0120 | R² = 0.9784 | MAE = 0.0002 | PR-AUC = 0.9940 | F1 = 0.9900 | Precision = 0.9900 | 2.41s</a:t>
+            </a:r>
+          </a:p>
+          <a:p>
+            <a:pPr>
+              <a:spcAft>
+                <a:spcPts val="1000"/>
+              </a:spcAft>
+              <a:defRPr sz="1500">
+                <a:solidFill>
+                  <a:srgbClr val="212529"/>
+                </a:solidFill>
+              </a:defRPr>
+            </a:pPr>
+            <a:r>
+              <a:t>• PyTorch fastai (Official): RMSE = 0.0584 | R² = 0.4859 | MAE = 0.0053 | PR-AUC = 0.5570 | F1 = 0.6710 | Precision = 0.9626 | 37.84s</a:t>
+            </a:r>
+          </a:p>
+          <a:p>
+            <a:pPr>
+              <a:spcAft>
+                <a:spcPts val="1000"/>
+              </a:spcAft>
+              <a:defRPr sz="1500">
+                <a:solidFill>
+                  <a:srgbClr val="212529"/>
+                </a:solidFill>
+              </a:defRPr>
+            </a:pPr>
+            <a:r>
+              <a:t>• PyTorch TabNet: RMSE = 0.0808 | R² = 0.0131 | MAE = 0.0298 | PR-AUC = 0.9339 | F1 = 0.6608 | Precision = 0.5081 | 44.86s</a:t>
+            </a:r>
+          </a:p>
+          <a:p>
+            <a:pPr>
+              <a:spcAft>
+                <a:spcPts val="1000"/>
+              </a:spcAft>
+              <a:defRPr sz="1500">
+                <a:solidFill>
+                  <a:srgbClr val="212529"/>
+                </a:solidFill>
+              </a:defRPr>
+            </a:pPr>
+            <a:r>
+              <a:t>• Keras MLP: RMSE = 0.0747 | R² = 0.1568 | MAE = 0.0186 | PR-AUC = 0.9146 | F1 = 0.6459 | Precision = 0.4934 | 43.29s</a:t>
+            </a:r>
+          </a:p>
+          <a:p>
+            <a:pPr>
+              <a:spcAft>
+                <a:spcPts val="1000"/>
+              </a:spcAft>
+              <a:defRPr sz="1500">
+                <a:solidFill>
+                  <a:srgbClr val="212529"/>
+                </a:solidFill>
+              </a:defRPr>
+            </a:pPr>
+            <a:r>
+              <a:t>• PyTorch Lightning (Substitute): RMSE = 0.0960 | R² = -0.3904 | MAE = 0.0328 | PR-AUC = 0.8998 | F1 = 0.5468 | Precision = 0.3864 | 31.85s</a:t>
+            </a:r>
+          </a:p>
+          <a:p>
+            <a:pPr>
+              <a:spcAft>
+                <a:spcPts val="1000"/>
+              </a:spcAft>
+              <a:defRPr sz="1500">
+                <a:solidFill>
+                  <a:srgbClr val="212529"/>
+                </a:solidFill>
+              </a:defRPr>
+            </a:pPr>
+            <a:r>
+              <a:t>• Validation Threshold Finding: Fastai at val-selected tau=0.57 achieved 100% test precision (FP=0, F1=0.6799).</a:t>
             </a:r>
           </a:p>
         </p:txBody>

</xml_diff>